<commit_message>
Added formatting, lines and backgrounds
</commit_message>
<xml_diff>
--- a/apps/web-demo/src/Presentation1.pptx
+++ b/apps/web-demo/src/Presentation1.pptx
@@ -105,6 +105,11 @@
       </a:defRPr>
     </a:lvl9pPr>
   </p:defaultTextStyle>
+  <p:extLst>
+    <p:ext uri="{EFAFB233-063F-42B5-8137-9DF3F51BA10A}">
+      <p15:sldGuideLst xmlns:p15="http://schemas.microsoft.com/office/powerpoint/2012/main"/>
+    </p:ext>
+  </p:extLst>
 </p:presentation>
 </file>
 
@@ -257,7 +262,7 @@
           <a:p>
             <a:fld id="{7855FD8B-6E15-6A40-8498-FD85B722A7EB}" type="datetimeFigureOut">
               <a:rPr lang="en-US" smtClean="0"/>
-              <a:t>7/29/26</a:t>
+              <a:t>7/30/26</a:t>
             </a:fld>
             <a:endParaRPr lang="en-US"/>
           </a:p>
@@ -457,7 +462,7 @@
           <a:p>
             <a:fld id="{7855FD8B-6E15-6A40-8498-FD85B722A7EB}" type="datetimeFigureOut">
               <a:rPr lang="en-US" smtClean="0"/>
-              <a:t>7/29/26</a:t>
+              <a:t>7/30/26</a:t>
             </a:fld>
             <a:endParaRPr lang="en-US"/>
           </a:p>
@@ -667,7 +672,7 @@
           <a:p>
             <a:fld id="{7855FD8B-6E15-6A40-8498-FD85B722A7EB}" type="datetimeFigureOut">
               <a:rPr lang="en-US" smtClean="0"/>
-              <a:t>7/29/26</a:t>
+              <a:t>7/30/26</a:t>
             </a:fld>
             <a:endParaRPr lang="en-US"/>
           </a:p>
@@ -867,7 +872,7 @@
           <a:p>
             <a:fld id="{7855FD8B-6E15-6A40-8498-FD85B722A7EB}" type="datetimeFigureOut">
               <a:rPr lang="en-US" smtClean="0"/>
-              <a:t>7/29/26</a:t>
+              <a:t>7/30/26</a:t>
             </a:fld>
             <a:endParaRPr lang="en-US"/>
           </a:p>
@@ -1143,7 +1148,7 @@
           <a:p>
             <a:fld id="{7855FD8B-6E15-6A40-8498-FD85B722A7EB}" type="datetimeFigureOut">
               <a:rPr lang="en-US" smtClean="0"/>
-              <a:t>7/29/26</a:t>
+              <a:t>7/30/26</a:t>
             </a:fld>
             <a:endParaRPr lang="en-US"/>
           </a:p>
@@ -1411,7 +1416,7 @@
           <a:p>
             <a:fld id="{7855FD8B-6E15-6A40-8498-FD85B722A7EB}" type="datetimeFigureOut">
               <a:rPr lang="en-US" smtClean="0"/>
-              <a:t>7/29/26</a:t>
+              <a:t>7/30/26</a:t>
             </a:fld>
             <a:endParaRPr lang="en-US"/>
           </a:p>
@@ -1826,7 +1831,7 @@
           <a:p>
             <a:fld id="{7855FD8B-6E15-6A40-8498-FD85B722A7EB}" type="datetimeFigureOut">
               <a:rPr lang="en-US" smtClean="0"/>
-              <a:t>7/29/26</a:t>
+              <a:t>7/30/26</a:t>
             </a:fld>
             <a:endParaRPr lang="en-US"/>
           </a:p>
@@ -1968,7 +1973,7 @@
           <a:p>
             <a:fld id="{7855FD8B-6E15-6A40-8498-FD85B722A7EB}" type="datetimeFigureOut">
               <a:rPr lang="en-US" smtClean="0"/>
-              <a:t>7/29/26</a:t>
+              <a:t>7/30/26</a:t>
             </a:fld>
             <a:endParaRPr lang="en-US"/>
           </a:p>
@@ -2081,7 +2086,7 @@
           <a:p>
             <a:fld id="{7855FD8B-6E15-6A40-8498-FD85B722A7EB}" type="datetimeFigureOut">
               <a:rPr lang="en-US" smtClean="0"/>
-              <a:t>7/29/26</a:t>
+              <a:t>7/30/26</a:t>
             </a:fld>
             <a:endParaRPr lang="en-US"/>
           </a:p>
@@ -2394,7 +2399,7 @@
           <a:p>
             <a:fld id="{7855FD8B-6E15-6A40-8498-FD85B722A7EB}" type="datetimeFigureOut">
               <a:rPr lang="en-US" smtClean="0"/>
-              <a:t>7/29/26</a:t>
+              <a:t>7/30/26</a:t>
             </a:fld>
             <a:endParaRPr lang="en-US"/>
           </a:p>
@@ -2683,7 +2688,7 @@
           <a:p>
             <a:fld id="{7855FD8B-6E15-6A40-8498-FD85B722A7EB}" type="datetimeFigureOut">
               <a:rPr lang="en-US" smtClean="0"/>
-              <a:t>7/29/26</a:t>
+              <a:t>7/30/26</a:t>
             </a:fld>
             <a:endParaRPr lang="en-US"/>
           </a:p>
@@ -2926,7 +2931,7 @@
           <a:p>
             <a:fld id="{7855FD8B-6E15-6A40-8498-FD85B722A7EB}" type="datetimeFigureOut">
               <a:rPr lang="en-US" smtClean="0"/>
-              <a:t>7/29/26</a:t>
+              <a:t>7/30/26</a:t>
             </a:fld>
             <a:endParaRPr lang="en-US"/>
           </a:p>
@@ -3329,6 +3334,17 @@
 <file path=ppt/slides/slide1.xml><?xml version="1.0" encoding="utf-8"?>
 <p:sld xmlns:a="http://schemas.openxmlformats.org/drawingml/2006/main" xmlns:r="http://schemas.openxmlformats.org/officeDocument/2006/relationships" xmlns:p="http://schemas.openxmlformats.org/presentationml/2006/main">
   <p:cSld>
+    <p:bg>
+      <p:bgPr>
+        <a:solidFill>
+          <a:schemeClr val="accent6">
+            <a:lumMod val="20000"/>
+            <a:lumOff val="80000"/>
+          </a:schemeClr>
+        </a:solidFill>
+        <a:effectLst/>
+      </p:bgPr>
+    </p:bg>
     <p:spTree>
       <p:nvGrpSpPr>
         <p:cNvPr id="1" name=""/>
@@ -3359,13 +3375,44 @@
             <p:ph type="ctrTitle"/>
           </p:nvPr>
         </p:nvSpPr>
-        <p:spPr/>
-        <p:txBody>
-          <a:bodyPr/>
-          <a:lstStyle/>
-          <a:p>
-            <a:r>
-              <a:rPr lang="en-US" dirty="0"/>
+        <p:spPr>
+          <a:gradFill flip="none" rotWithShape="1">
+            <a:gsLst>
+              <a:gs pos="0">
+                <a:schemeClr val="tx2"/>
+              </a:gs>
+              <a:gs pos="50000">
+                <a:schemeClr val="tx2">
+                  <a:lumMod val="75000"/>
+                  <a:lumOff val="25000"/>
+                </a:schemeClr>
+              </a:gs>
+              <a:gs pos="100000">
+                <a:schemeClr val="tx2">
+                  <a:lumMod val="75000"/>
+                  <a:lumOff val="25000"/>
+                </a:schemeClr>
+              </a:gs>
+            </a:gsLst>
+            <a:lin ang="2700000" scaled="1"/>
+            <a:tileRect/>
+          </a:gradFill>
+        </p:spPr>
+        <p:txBody>
+          <a:bodyPr/>
+          <a:lstStyle/>
+          <a:p>
+            <a:r>
+              <a:rPr lang="en-US" dirty="0">
+                <a:solidFill>
+                  <a:schemeClr val="bg1">
+                    <a:lumMod val="85000"/>
+                  </a:schemeClr>
+                </a:solidFill>
+                <a:latin typeface="Tahoma" panose="020B0604030504040204" pitchFamily="34" charset="0"/>
+                <a:ea typeface="Tahoma" panose="020B0604030504040204" pitchFamily="34" charset="0"/>
+                <a:cs typeface="Tahoma" panose="020B0604030504040204" pitchFamily="34" charset="0"/>
+              </a:rPr>
               <a:t>Title 1</a:t>
             </a:r>
           </a:p>
@@ -3387,13 +3434,33 @@
             <p:ph type="subTitle" idx="1"/>
           </p:nvPr>
         </p:nvSpPr>
-        <p:spPr/>
-        <p:txBody>
-          <a:bodyPr/>
-          <a:lstStyle/>
-          <a:p>
-            <a:r>
-              <a:rPr lang="en-US" dirty="0"/>
+        <p:spPr>
+          <a:ln w="63500">
+            <a:round/>
+          </a:ln>
+        </p:spPr>
+        <p:style>
+          <a:lnRef idx="2">
+            <a:schemeClr val="dk1"/>
+          </a:lnRef>
+          <a:fillRef idx="1">
+            <a:schemeClr val="lt1"/>
+          </a:fillRef>
+          <a:effectRef idx="0">
+            <a:schemeClr val="dk1"/>
+          </a:effectRef>
+          <a:fontRef idx="minor">
+            <a:schemeClr val="dk1"/>
+          </a:fontRef>
+        </p:style>
+        <p:txBody>
+          <a:bodyPr/>
+          <a:lstStyle/>
+          <a:p>
+            <a:r>
+              <a:rPr lang="en-US" b="1" i="1" dirty="0">
+                <a:latin typeface="Comic Sans MS" panose="030F0902030302020204" pitchFamily="66" charset="0"/>
+              </a:rPr>
               <a:t>James</a:t>
             </a:r>
           </a:p>

</xml_diff>

<commit_message>
Scaling text + borders etc., also inherited alignment works.
</commit_message>
<xml_diff>
--- a/apps/web-demo/src/Presentation1.pptx
+++ b/apps/web-demo/src/Presentation1.pptx
@@ -3556,6 +3556,23 @@
               <a:t>Two</a:t>
             </a:r>
           </a:p>
+          <a:p>
+            <a:endParaRPr lang="en-US" dirty="0"/>
+          </a:p>
+          <a:p>
+            <a:pPr marL="0" indent="0">
+              <a:buNone/>
+            </a:pPr>
+            <a:r>
+              <a:rPr lang="en-US" dirty="0"/>
+              <a:t>And now some more text which takes up rather more space than anything we’ve seen so far. Hopefully this will stress-test the rendering a </a:t>
+            </a:r>
+            <a:r>
+              <a:rPr lang="en-US"/>
+              <a:t>bit more.</a:t>
+            </a:r>
+            <a:endParaRPr lang="en-US" dirty="0"/>
+          </a:p>
         </p:txBody>
       </p:sp>
     </p:spTree>

</xml_diff>

<commit_message>
Shapes, including inherited properties
</commit_message>
<xml_diff>
--- a/apps/web-demo/src/Presentation1.pptx
+++ b/apps/web-demo/src/Presentation1.pptx
@@ -3466,6 +3466,101 @@
           </a:p>
         </p:txBody>
       </p:sp>
+      <p:sp>
+        <p:nvSpPr>
+          <p:cNvPr id="4" name="Oval 3">
+            <a:extLst>
+              <a:ext uri="{FF2B5EF4-FFF2-40B4-BE49-F238E27FC236}">
+                <a16:creationId xmlns:a16="http://schemas.microsoft.com/office/drawing/2014/main" id="{CF4056A0-572C-C58A-9500-1B82FB23F97A}"/>
+              </a:ext>
+            </a:extLst>
+          </p:cNvPr>
+          <p:cNvSpPr/>
+          <p:nvPr/>
+        </p:nvSpPr>
+        <p:spPr>
+          <a:xfrm>
+            <a:off x="489098" y="5794744"/>
+            <a:ext cx="786809" cy="786809"/>
+          </a:xfrm>
+          <a:prstGeom prst="ellipse">
+            <a:avLst/>
+          </a:prstGeom>
+        </p:spPr>
+        <p:style>
+          <a:lnRef idx="2">
+            <a:schemeClr val="accent1">
+              <a:shade val="15000"/>
+            </a:schemeClr>
+          </a:lnRef>
+          <a:fillRef idx="1">
+            <a:schemeClr val="accent1"/>
+          </a:fillRef>
+          <a:effectRef idx="0">
+            <a:schemeClr val="accent1"/>
+          </a:effectRef>
+          <a:fontRef idx="minor">
+            <a:schemeClr val="lt1"/>
+          </a:fontRef>
+        </p:style>
+        <p:txBody>
+          <a:bodyPr rtlCol="0" anchor="ctr"/>
+          <a:lstStyle/>
+          <a:p>
+            <a:pPr algn="ctr"/>
+            <a:r>
+              <a:rPr lang="en-US" dirty="0"/>
+              <a:t>42</a:t>
+            </a:r>
+          </a:p>
+        </p:txBody>
+      </p:sp>
+      <p:sp>
+        <p:nvSpPr>
+          <p:cNvPr id="5" name="5-point Star 4">
+            <a:extLst>
+              <a:ext uri="{FF2B5EF4-FFF2-40B4-BE49-F238E27FC236}">
+                <a16:creationId xmlns:a16="http://schemas.microsoft.com/office/drawing/2014/main" id="{3CF397E7-AC46-0C0C-7D95-DF66270B04D4}"/>
+              </a:ext>
+            </a:extLst>
+          </p:cNvPr>
+          <p:cNvSpPr/>
+          <p:nvPr/>
+        </p:nvSpPr>
+        <p:spPr>
+          <a:xfrm>
+            <a:off x="489098" y="542260"/>
+            <a:ext cx="1034902" cy="984250"/>
+          </a:xfrm>
+          <a:prstGeom prst="star5">
+            <a:avLst/>
+          </a:prstGeom>
+        </p:spPr>
+        <p:style>
+          <a:lnRef idx="2">
+            <a:schemeClr val="accent1">
+              <a:shade val="15000"/>
+            </a:schemeClr>
+          </a:lnRef>
+          <a:fillRef idx="1">
+            <a:schemeClr val="accent1"/>
+          </a:fillRef>
+          <a:effectRef idx="0">
+            <a:schemeClr val="accent1"/>
+          </a:effectRef>
+          <a:fontRef idx="minor">
+            <a:schemeClr val="lt1"/>
+          </a:fontRef>
+        </p:style>
+        <p:txBody>
+          <a:bodyPr rtlCol="0" anchor="ctr"/>
+          <a:lstStyle/>
+          <a:p>
+            <a:pPr algn="ctr"/>
+            <a:endParaRPr lang="en-US"/>
+          </a:p>
+        </p:txBody>
+      </p:sp>
     </p:spTree>
     <p:extLst>
       <p:ext uri="{BB962C8B-B14F-4D97-AF65-F5344CB8AC3E}">

</xml_diff>

<commit_message>
Animation OM + reader
</commit_message>
<xml_diff>
--- a/apps/web-demo/src/Presentation1.pptx
+++ b/apps/web-demo/src/Presentation1.pptx
@@ -262,7 +262,7 @@
           <a:p>
             <a:fld id="{7855FD8B-6E15-6A40-8498-FD85B722A7EB}" type="datetimeFigureOut">
               <a:rPr lang="en-US" smtClean="0"/>
-              <a:t>7/30/26</a:t>
+              <a:t>8/1/26</a:t>
             </a:fld>
             <a:endParaRPr lang="en-US"/>
           </a:p>
@@ -462,7 +462,7 @@
           <a:p>
             <a:fld id="{7855FD8B-6E15-6A40-8498-FD85B722A7EB}" type="datetimeFigureOut">
               <a:rPr lang="en-US" smtClean="0"/>
-              <a:t>7/30/26</a:t>
+              <a:t>8/1/26</a:t>
             </a:fld>
             <a:endParaRPr lang="en-US"/>
           </a:p>
@@ -672,7 +672,7 @@
           <a:p>
             <a:fld id="{7855FD8B-6E15-6A40-8498-FD85B722A7EB}" type="datetimeFigureOut">
               <a:rPr lang="en-US" smtClean="0"/>
-              <a:t>7/30/26</a:t>
+              <a:t>8/1/26</a:t>
             </a:fld>
             <a:endParaRPr lang="en-US"/>
           </a:p>
@@ -872,7 +872,7 @@
           <a:p>
             <a:fld id="{7855FD8B-6E15-6A40-8498-FD85B722A7EB}" type="datetimeFigureOut">
               <a:rPr lang="en-US" smtClean="0"/>
-              <a:t>7/30/26</a:t>
+              <a:t>8/1/26</a:t>
             </a:fld>
             <a:endParaRPr lang="en-US"/>
           </a:p>
@@ -1148,7 +1148,7 @@
           <a:p>
             <a:fld id="{7855FD8B-6E15-6A40-8498-FD85B722A7EB}" type="datetimeFigureOut">
               <a:rPr lang="en-US" smtClean="0"/>
-              <a:t>7/30/26</a:t>
+              <a:t>8/1/26</a:t>
             </a:fld>
             <a:endParaRPr lang="en-US"/>
           </a:p>
@@ -1416,7 +1416,7 @@
           <a:p>
             <a:fld id="{7855FD8B-6E15-6A40-8498-FD85B722A7EB}" type="datetimeFigureOut">
               <a:rPr lang="en-US" smtClean="0"/>
-              <a:t>7/30/26</a:t>
+              <a:t>8/1/26</a:t>
             </a:fld>
             <a:endParaRPr lang="en-US"/>
           </a:p>
@@ -1831,7 +1831,7 @@
           <a:p>
             <a:fld id="{7855FD8B-6E15-6A40-8498-FD85B722A7EB}" type="datetimeFigureOut">
               <a:rPr lang="en-US" smtClean="0"/>
-              <a:t>7/30/26</a:t>
+              <a:t>8/1/26</a:t>
             </a:fld>
             <a:endParaRPr lang="en-US"/>
           </a:p>
@@ -1973,7 +1973,7 @@
           <a:p>
             <a:fld id="{7855FD8B-6E15-6A40-8498-FD85B722A7EB}" type="datetimeFigureOut">
               <a:rPr lang="en-US" smtClean="0"/>
-              <a:t>7/30/26</a:t>
+              <a:t>8/1/26</a:t>
             </a:fld>
             <a:endParaRPr lang="en-US"/>
           </a:p>
@@ -2086,7 +2086,7 @@
           <a:p>
             <a:fld id="{7855FD8B-6E15-6A40-8498-FD85B722A7EB}" type="datetimeFigureOut">
               <a:rPr lang="en-US" smtClean="0"/>
-              <a:t>7/30/26</a:t>
+              <a:t>8/1/26</a:t>
             </a:fld>
             <a:endParaRPr lang="en-US"/>
           </a:p>
@@ -2399,7 +2399,7 @@
           <a:p>
             <a:fld id="{7855FD8B-6E15-6A40-8498-FD85B722A7EB}" type="datetimeFigureOut">
               <a:rPr lang="en-US" smtClean="0"/>
-              <a:t>7/30/26</a:t>
+              <a:t>8/1/26</a:t>
             </a:fld>
             <a:endParaRPr lang="en-US"/>
           </a:p>
@@ -2688,7 +2688,7 @@
           <a:p>
             <a:fld id="{7855FD8B-6E15-6A40-8498-FD85B722A7EB}" type="datetimeFigureOut">
               <a:rPr lang="en-US" smtClean="0"/>
-              <a:t>7/30/26</a:t>
+              <a:t>8/1/26</a:t>
             </a:fld>
             <a:endParaRPr lang="en-US"/>
           </a:p>
@@ -2931,7 +2931,7 @@
           <a:p>
             <a:fld id="{7855FD8B-6E15-6A40-8498-FD85B722A7EB}" type="datetimeFigureOut">
               <a:rPr lang="en-US" smtClean="0"/>
-              <a:t>7/30/26</a:t>
+              <a:t>8/1/26</a:t>
             </a:fld>
             <a:endParaRPr lang="en-US"/>
           </a:p>
@@ -3571,6 +3571,239 @@
   <p:clrMapOvr>
     <a:masterClrMapping/>
   </p:clrMapOvr>
+  <p:timing>
+    <p:tnLst>
+      <p:par>
+        <p:cTn id="1" dur="indefinite" restart="never" nodeType="tmRoot">
+          <p:childTnLst>
+            <p:seq concurrent="1" nextAc="seek">
+              <p:cTn id="2" dur="indefinite" nodeType="mainSeq">
+                <p:childTnLst>
+                  <p:par>
+                    <p:cTn id="3" fill="hold">
+                      <p:stCondLst>
+                        <p:cond delay="indefinite"/>
+                      </p:stCondLst>
+                      <p:childTnLst>
+                        <p:par>
+                          <p:cTn id="4" fill="hold">
+                            <p:stCondLst>
+                              <p:cond delay="0"/>
+                            </p:stCondLst>
+                            <p:childTnLst>
+                              <p:par>
+                                <p:cTn id="5" presetID="2" presetClass="entr" presetSubtype="4" fill="hold" grpId="0" nodeType="clickEffect">
+                                  <p:stCondLst>
+                                    <p:cond delay="0"/>
+                                  </p:stCondLst>
+                                  <p:childTnLst>
+                                    <p:set>
+                                      <p:cBhvr>
+                                        <p:cTn id="6" dur="1" fill="hold">
+                                          <p:stCondLst>
+                                            <p:cond delay="0"/>
+                                          </p:stCondLst>
+                                        </p:cTn>
+                                        <p:tgtEl>
+                                          <p:spTgt spid="3">
+                                            <p:bg/>
+                                          </p:spTgt>
+                                        </p:tgtEl>
+                                        <p:attrNameLst>
+                                          <p:attrName>style.visibility</p:attrName>
+                                        </p:attrNameLst>
+                                      </p:cBhvr>
+                                      <p:to>
+                                        <p:strVal val="visible"/>
+                                      </p:to>
+                                    </p:set>
+                                    <p:anim calcmode="lin" valueType="num">
+                                      <p:cBhvr additive="base">
+                                        <p:cTn id="7" dur="500" fill="hold"/>
+                                        <p:tgtEl>
+                                          <p:spTgt spid="3">
+                                            <p:bg/>
+                                          </p:spTgt>
+                                        </p:tgtEl>
+                                        <p:attrNameLst>
+                                          <p:attrName>ppt_x</p:attrName>
+                                        </p:attrNameLst>
+                                      </p:cBhvr>
+                                      <p:tavLst>
+                                        <p:tav tm="0">
+                                          <p:val>
+                                            <p:strVal val="#ppt_x"/>
+                                          </p:val>
+                                        </p:tav>
+                                        <p:tav tm="100000">
+                                          <p:val>
+                                            <p:strVal val="#ppt_x"/>
+                                          </p:val>
+                                        </p:tav>
+                                      </p:tavLst>
+                                    </p:anim>
+                                    <p:anim calcmode="lin" valueType="num">
+                                      <p:cBhvr additive="base">
+                                        <p:cTn id="8" dur="500" fill="hold"/>
+                                        <p:tgtEl>
+                                          <p:spTgt spid="3">
+                                            <p:bg/>
+                                          </p:spTgt>
+                                        </p:tgtEl>
+                                        <p:attrNameLst>
+                                          <p:attrName>ppt_y</p:attrName>
+                                        </p:attrNameLst>
+                                      </p:cBhvr>
+                                      <p:tavLst>
+                                        <p:tav tm="0">
+                                          <p:val>
+                                            <p:strVal val="1+#ppt_h/2"/>
+                                          </p:val>
+                                        </p:tav>
+                                        <p:tav tm="100000">
+                                          <p:val>
+                                            <p:strVal val="#ppt_y"/>
+                                          </p:val>
+                                        </p:tav>
+                                      </p:tavLst>
+                                    </p:anim>
+                                  </p:childTnLst>
+                                </p:cTn>
+                              </p:par>
+                            </p:childTnLst>
+                          </p:cTn>
+                        </p:par>
+                      </p:childTnLst>
+                    </p:cTn>
+                  </p:par>
+                  <p:par>
+                    <p:cTn id="9" fill="hold">
+                      <p:stCondLst>
+                        <p:cond delay="indefinite"/>
+                      </p:stCondLst>
+                      <p:childTnLst>
+                        <p:par>
+                          <p:cTn id="10" fill="hold">
+                            <p:stCondLst>
+                              <p:cond delay="0"/>
+                            </p:stCondLst>
+                            <p:childTnLst>
+                              <p:par>
+                                <p:cTn id="11" presetID="2" presetClass="entr" presetSubtype="4" fill="hold" grpId="0" nodeType="clickEffect">
+                                  <p:stCondLst>
+                                    <p:cond delay="0"/>
+                                  </p:stCondLst>
+                                  <p:childTnLst>
+                                    <p:set>
+                                      <p:cBhvr>
+                                        <p:cTn id="12" dur="1" fill="hold">
+                                          <p:stCondLst>
+                                            <p:cond delay="0"/>
+                                          </p:stCondLst>
+                                        </p:cTn>
+                                        <p:tgtEl>
+                                          <p:spTgt spid="3">
+                                            <p:txEl>
+                                              <p:pRg st="0" end="0"/>
+                                            </p:txEl>
+                                          </p:spTgt>
+                                        </p:tgtEl>
+                                        <p:attrNameLst>
+                                          <p:attrName>style.visibility</p:attrName>
+                                        </p:attrNameLst>
+                                      </p:cBhvr>
+                                      <p:to>
+                                        <p:strVal val="visible"/>
+                                      </p:to>
+                                    </p:set>
+                                    <p:anim calcmode="lin" valueType="num">
+                                      <p:cBhvr additive="base">
+                                        <p:cTn id="13" dur="500" fill="hold"/>
+                                        <p:tgtEl>
+                                          <p:spTgt spid="3">
+                                            <p:txEl>
+                                              <p:pRg st="0" end="0"/>
+                                            </p:txEl>
+                                          </p:spTgt>
+                                        </p:tgtEl>
+                                        <p:attrNameLst>
+                                          <p:attrName>ppt_x</p:attrName>
+                                        </p:attrNameLst>
+                                      </p:cBhvr>
+                                      <p:tavLst>
+                                        <p:tav tm="0">
+                                          <p:val>
+                                            <p:strVal val="#ppt_x"/>
+                                          </p:val>
+                                        </p:tav>
+                                        <p:tav tm="100000">
+                                          <p:val>
+                                            <p:strVal val="#ppt_x"/>
+                                          </p:val>
+                                        </p:tav>
+                                      </p:tavLst>
+                                    </p:anim>
+                                    <p:anim calcmode="lin" valueType="num">
+                                      <p:cBhvr additive="base">
+                                        <p:cTn id="14" dur="500" fill="hold"/>
+                                        <p:tgtEl>
+                                          <p:spTgt spid="3">
+                                            <p:txEl>
+                                              <p:pRg st="0" end="0"/>
+                                            </p:txEl>
+                                          </p:spTgt>
+                                        </p:tgtEl>
+                                        <p:attrNameLst>
+                                          <p:attrName>ppt_y</p:attrName>
+                                        </p:attrNameLst>
+                                      </p:cBhvr>
+                                      <p:tavLst>
+                                        <p:tav tm="0">
+                                          <p:val>
+                                            <p:strVal val="1+#ppt_h/2"/>
+                                          </p:val>
+                                        </p:tav>
+                                        <p:tav tm="100000">
+                                          <p:val>
+                                            <p:strVal val="#ppt_y"/>
+                                          </p:val>
+                                        </p:tav>
+                                      </p:tavLst>
+                                    </p:anim>
+                                  </p:childTnLst>
+                                </p:cTn>
+                              </p:par>
+                            </p:childTnLst>
+                          </p:cTn>
+                        </p:par>
+                      </p:childTnLst>
+                    </p:cTn>
+                  </p:par>
+                </p:childTnLst>
+              </p:cTn>
+              <p:prevCondLst>
+                <p:cond evt="onPrev" delay="0">
+                  <p:tgtEl>
+                    <p:sldTgt/>
+                  </p:tgtEl>
+                </p:cond>
+              </p:prevCondLst>
+              <p:nextCondLst>
+                <p:cond evt="onNext" delay="0">
+                  <p:tgtEl>
+                    <p:sldTgt/>
+                  </p:tgtEl>
+                </p:cond>
+              </p:nextCondLst>
+            </p:seq>
+          </p:childTnLst>
+        </p:cTn>
+      </p:par>
+    </p:tnLst>
+    <p:bldLst>
+      <p:bldP spid="3" grpId="0" build="p" animBg="1"/>
+    </p:bldLst>
+  </p:timing>
 </p:sld>
 </file>
 

</xml_diff>

<commit_message>
Unsupported feature log added
</commit_message>
<xml_diff>
--- a/apps/web-demo/src/Presentation1.pptx
+++ b/apps/web-demo/src/Presentation1.pptx
@@ -263,7 +263,7 @@
           <a:p>
             <a:fld id="{7855FD8B-6E15-6A40-8498-FD85B722A7EB}" type="datetimeFigureOut">
               <a:rPr lang="en-US" smtClean="0"/>
-              <a:t>8/1/26</a:t>
+              <a:t>8/2/26</a:t>
             </a:fld>
             <a:endParaRPr lang="en-US"/>
           </a:p>
@@ -463,7 +463,7 @@
           <a:p>
             <a:fld id="{7855FD8B-6E15-6A40-8498-FD85B722A7EB}" type="datetimeFigureOut">
               <a:rPr lang="en-US" smtClean="0"/>
-              <a:t>8/1/26</a:t>
+              <a:t>8/2/26</a:t>
             </a:fld>
             <a:endParaRPr lang="en-US"/>
           </a:p>
@@ -673,7 +673,7 @@
           <a:p>
             <a:fld id="{7855FD8B-6E15-6A40-8498-FD85B722A7EB}" type="datetimeFigureOut">
               <a:rPr lang="en-US" smtClean="0"/>
-              <a:t>8/1/26</a:t>
+              <a:t>8/2/26</a:t>
             </a:fld>
             <a:endParaRPr lang="en-US"/>
           </a:p>
@@ -873,7 +873,7 @@
           <a:p>
             <a:fld id="{7855FD8B-6E15-6A40-8498-FD85B722A7EB}" type="datetimeFigureOut">
               <a:rPr lang="en-US" smtClean="0"/>
-              <a:t>8/1/26</a:t>
+              <a:t>8/2/26</a:t>
             </a:fld>
             <a:endParaRPr lang="en-US"/>
           </a:p>
@@ -1149,7 +1149,7 @@
           <a:p>
             <a:fld id="{7855FD8B-6E15-6A40-8498-FD85B722A7EB}" type="datetimeFigureOut">
               <a:rPr lang="en-US" smtClean="0"/>
-              <a:t>8/1/26</a:t>
+              <a:t>8/2/26</a:t>
             </a:fld>
             <a:endParaRPr lang="en-US"/>
           </a:p>
@@ -1417,7 +1417,7 @@
           <a:p>
             <a:fld id="{7855FD8B-6E15-6A40-8498-FD85B722A7EB}" type="datetimeFigureOut">
               <a:rPr lang="en-US" smtClean="0"/>
-              <a:t>8/1/26</a:t>
+              <a:t>8/2/26</a:t>
             </a:fld>
             <a:endParaRPr lang="en-US"/>
           </a:p>
@@ -1832,7 +1832,7 @@
           <a:p>
             <a:fld id="{7855FD8B-6E15-6A40-8498-FD85B722A7EB}" type="datetimeFigureOut">
               <a:rPr lang="en-US" smtClean="0"/>
-              <a:t>8/1/26</a:t>
+              <a:t>8/2/26</a:t>
             </a:fld>
             <a:endParaRPr lang="en-US"/>
           </a:p>
@@ -1974,7 +1974,7 @@
           <a:p>
             <a:fld id="{7855FD8B-6E15-6A40-8498-FD85B722A7EB}" type="datetimeFigureOut">
               <a:rPr lang="en-US" smtClean="0"/>
-              <a:t>8/1/26</a:t>
+              <a:t>8/2/26</a:t>
             </a:fld>
             <a:endParaRPr lang="en-US"/>
           </a:p>
@@ -2087,7 +2087,7 @@
           <a:p>
             <a:fld id="{7855FD8B-6E15-6A40-8498-FD85B722A7EB}" type="datetimeFigureOut">
               <a:rPr lang="en-US" smtClean="0"/>
-              <a:t>8/1/26</a:t>
+              <a:t>8/2/26</a:t>
             </a:fld>
             <a:endParaRPr lang="en-US"/>
           </a:p>
@@ -2400,7 +2400,7 @@
           <a:p>
             <a:fld id="{7855FD8B-6E15-6A40-8498-FD85B722A7EB}" type="datetimeFigureOut">
               <a:rPr lang="en-US" smtClean="0"/>
-              <a:t>8/1/26</a:t>
+              <a:t>8/2/26</a:t>
             </a:fld>
             <a:endParaRPr lang="en-US"/>
           </a:p>
@@ -2689,7 +2689,7 @@
           <a:p>
             <a:fld id="{7855FD8B-6E15-6A40-8498-FD85B722A7EB}" type="datetimeFigureOut">
               <a:rPr lang="en-US" smtClean="0"/>
-              <a:t>8/1/26</a:t>
+              <a:t>8/2/26</a:t>
             </a:fld>
             <a:endParaRPr lang="en-US"/>
           </a:p>
@@ -2932,7 +2932,7 @@
           <a:p>
             <a:fld id="{7855FD8B-6E15-6A40-8498-FD85B722A7EB}" type="datetimeFigureOut">
               <a:rPr lang="en-US" smtClean="0"/>
-              <a:t>8/1/26</a:t>
+              <a:t>8/2/26</a:t>
             </a:fld>
             <a:endParaRPr lang="en-US"/>
           </a:p>
@@ -3510,7 +3510,9 @@
           <a:p>
             <a:pPr algn="ctr"/>
             <a:r>
-              <a:rPr lang="en-US" dirty="0"/>
+              <a:rPr lang="en-US" sz="2400" b="1" dirty="0">
+                <a:latin typeface="Comic Sans MS" panose="030F0902030302020204" pitchFamily="66" charset="0"/>
+              </a:rPr>
               <a:t>42</a:t>
             </a:r>
           </a:p>
@@ -3593,7 +3595,7 @@
                             </p:stCondLst>
                             <p:childTnLst>
                               <p:par>
-                                <p:cTn id="5" presetID="2" presetClass="entr" presetSubtype="4" fill="hold" grpId="0" nodeType="clickEffect">
+                                <p:cTn id="5" presetID="10" presetClass="entr" presetSubtype="0" fill="hold" grpId="0" nodeType="clickEffect">
                                   <p:stCondLst>
                                     <p:cond delay="0"/>
                                   </p:stCondLst>
@@ -3618,56 +3620,16 @@
                                         <p:strVal val="visible"/>
                                       </p:to>
                                     </p:set>
-                                    <p:anim calcmode="lin" valueType="num">
-                                      <p:cBhvr additive="base">
-                                        <p:cTn id="7" dur="500" fill="hold"/>
+                                    <p:animEffect transition="in" filter="fade">
+                                      <p:cBhvr>
+                                        <p:cTn id="7" dur="500"/>
                                         <p:tgtEl>
                                           <p:spTgt spid="3">
                                             <p:bg/>
                                           </p:spTgt>
                                         </p:tgtEl>
-                                        <p:attrNameLst>
-                                          <p:attrName>ppt_x</p:attrName>
-                                        </p:attrNameLst>
                                       </p:cBhvr>
-                                      <p:tavLst>
-                                        <p:tav tm="0">
-                                          <p:val>
-                                            <p:strVal val="#ppt_x"/>
-                                          </p:val>
-                                        </p:tav>
-                                        <p:tav tm="100000">
-                                          <p:val>
-                                            <p:strVal val="#ppt_x"/>
-                                          </p:val>
-                                        </p:tav>
-                                      </p:tavLst>
-                                    </p:anim>
-                                    <p:anim calcmode="lin" valueType="num">
-                                      <p:cBhvr additive="base">
-                                        <p:cTn id="8" dur="500" fill="hold"/>
-                                        <p:tgtEl>
-                                          <p:spTgt spid="3">
-                                            <p:bg/>
-                                          </p:spTgt>
-                                        </p:tgtEl>
-                                        <p:attrNameLst>
-                                          <p:attrName>ppt_y</p:attrName>
-                                        </p:attrNameLst>
-                                      </p:cBhvr>
-                                      <p:tavLst>
-                                        <p:tav tm="0">
-                                          <p:val>
-                                            <p:strVal val="1+#ppt_h/2"/>
-                                          </p:val>
-                                        </p:tav>
-                                        <p:tav tm="100000">
-                                          <p:val>
-                                            <p:strVal val="#ppt_y"/>
-                                          </p:val>
-                                        </p:tav>
-                                      </p:tavLst>
-                                    </p:anim>
+                                    </p:animEffect>
                                   </p:childTnLst>
                                 </p:cTn>
                               </p:par>
@@ -3678,26 +3640,26 @@
                     </p:cTn>
                   </p:par>
                   <p:par>
-                    <p:cTn id="9" fill="hold">
+                    <p:cTn id="8" fill="hold">
                       <p:stCondLst>
                         <p:cond delay="indefinite"/>
                       </p:stCondLst>
                       <p:childTnLst>
                         <p:par>
-                          <p:cTn id="10" fill="hold">
+                          <p:cTn id="9" fill="hold">
                             <p:stCondLst>
                               <p:cond delay="0"/>
                             </p:stCondLst>
                             <p:childTnLst>
                               <p:par>
-                                <p:cTn id="11" presetID="2" presetClass="entr" presetSubtype="4" fill="hold" grpId="0" nodeType="clickEffect">
+                                <p:cTn id="10" presetID="10" presetClass="entr" presetSubtype="0" fill="hold" grpId="0" nodeType="clickEffect">
                                   <p:stCondLst>
                                     <p:cond delay="0"/>
                                   </p:stCondLst>
                                   <p:childTnLst>
                                     <p:set>
                                       <p:cBhvr>
-                                        <p:cTn id="12" dur="1" fill="hold">
+                                        <p:cTn id="11" dur="1" fill="hold">
                                           <p:stCondLst>
                                             <p:cond delay="0"/>
                                           </p:stCondLst>
@@ -3717,9 +3679,9 @@
                                         <p:strVal val="visible"/>
                                       </p:to>
                                     </p:set>
-                                    <p:anim calcmode="lin" valueType="num">
-                                      <p:cBhvr additive="base">
-                                        <p:cTn id="13" dur="500" fill="hold"/>
+                                    <p:animEffect transition="in" filter="fade">
+                                      <p:cBhvr>
+                                        <p:cTn id="12" dur="500"/>
                                         <p:tgtEl>
                                           <p:spTgt spid="3">
                                             <p:txEl>
@@ -3727,50 +3689,8 @@
                                             </p:txEl>
                                           </p:spTgt>
                                         </p:tgtEl>
-                                        <p:attrNameLst>
-                                          <p:attrName>ppt_x</p:attrName>
-                                        </p:attrNameLst>
                                       </p:cBhvr>
-                                      <p:tavLst>
-                                        <p:tav tm="0">
-                                          <p:val>
-                                            <p:strVal val="#ppt_x"/>
-                                          </p:val>
-                                        </p:tav>
-                                        <p:tav tm="100000">
-                                          <p:val>
-                                            <p:strVal val="#ppt_x"/>
-                                          </p:val>
-                                        </p:tav>
-                                      </p:tavLst>
-                                    </p:anim>
-                                    <p:anim calcmode="lin" valueType="num">
-                                      <p:cBhvr additive="base">
-                                        <p:cTn id="14" dur="500" fill="hold"/>
-                                        <p:tgtEl>
-                                          <p:spTgt spid="3">
-                                            <p:txEl>
-                                              <p:pRg st="0" end="0"/>
-                                            </p:txEl>
-                                          </p:spTgt>
-                                        </p:tgtEl>
-                                        <p:attrNameLst>
-                                          <p:attrName>ppt_y</p:attrName>
-                                        </p:attrNameLst>
-                                      </p:cBhvr>
-                                      <p:tavLst>
-                                        <p:tav tm="0">
-                                          <p:val>
-                                            <p:strVal val="1+#ppt_h/2"/>
-                                          </p:val>
-                                        </p:tav>
-                                        <p:tav tm="100000">
-                                          <p:val>
-                                            <p:strVal val="#ppt_y"/>
-                                          </p:val>
-                                        </p:tav>
-                                      </p:tavLst>
-                                    </p:anim>
+                                    </p:animEffect>
                                   </p:childTnLst>
                                 </p:cTn>
                               </p:par>
@@ -3914,18 +3834,9 @@
   <p:clrMapOvr>
     <a:masterClrMapping/>
   </p:clrMapOvr>
-  <mc:AlternateContent xmlns:mc="http://schemas.openxmlformats.org/markup-compatibility/2006">
-    <mc:Choice xmlns:p14="http://schemas.microsoft.com/office/powerpoint/2010/main" Requires="p14">
-      <p:transition spd="med" p14:dur="700">
-        <p:fade/>
-      </p:transition>
-    </mc:Choice>
-    <mc:Fallback>
-      <p:transition spd="med">
-        <p:fade/>
-      </p:transition>
-    </mc:Fallback>
-  </mc:AlternateContent>
+  <p:transition spd="slow">
+    <p:wipe/>
+  </p:transition>
 </p:sld>
 </file>
 
@@ -4007,6 +3918,42 @@
             <a:off x="3439296" y="2765617"/>
             <a:ext cx="2862649" cy="2862649"/>
           </a:xfrm>
+        </p:spPr>
+      </p:pic>
+      <p:pic>
+        <p:nvPicPr>
+          <p:cNvPr id="4" name="Graphic 3" descr="Aeroplane outline">
+            <a:extLst>
+              <a:ext uri="{FF2B5EF4-FFF2-40B4-BE49-F238E27FC236}">
+                <a16:creationId xmlns:a16="http://schemas.microsoft.com/office/drawing/2014/main" id="{CCF096A5-06ED-E559-4726-5278CED25888}"/>
+              </a:ext>
+            </a:extLst>
+          </p:cNvPr>
+          <p:cNvPicPr>
+            <a:picLocks noChangeAspect="1"/>
+          </p:cNvPicPr>
+          <p:nvPr/>
+        </p:nvPicPr>
+        <p:blipFill>
+          <a:blip>
+            <a:extLst>
+              <a:ext uri="{96DAC541-7B7A-43D3-8B79-37D633B846F1}">
+                <asvg:svgBlip xmlns:asvg="http://schemas.microsoft.com/office/drawing/2016/SVG/main" r:embed="rId3"/>
+              </a:ext>
+            </a:extLst>
+          </a:blip>
+          <a:stretch>
+            <a:fillRect/>
+          </a:stretch>
+        </p:blipFill>
+        <p:spPr>
+          <a:xfrm>
+            <a:off x="7850659" y="1690688"/>
+            <a:ext cx="914400" cy="914400"/>
+          </a:xfrm>
+          <a:prstGeom prst="rect">
+            <a:avLst/>
+          </a:prstGeom>
         </p:spPr>
       </p:pic>
     </p:spTree>

</xml_diff>

<commit_message>
Various minor presentation fixes
</commit_message>
<xml_diff>
--- a/apps/web-demo/src/Presentation1.pptx
+++ b/apps/web-demo/src/Presentation1.pptx
@@ -264,7 +264,7 @@
           <a:p>
             <a:fld id="{7855FD8B-6E15-6A40-8498-FD85B722A7EB}" type="datetimeFigureOut">
               <a:rPr lang="en-US" smtClean="0"/>
-              <a:t>8/4/26</a:t>
+              <a:t>8/8/26</a:t>
             </a:fld>
             <a:endParaRPr lang="en-US"/>
           </a:p>
@@ -464,7 +464,7 @@
           <a:p>
             <a:fld id="{7855FD8B-6E15-6A40-8498-FD85B722A7EB}" type="datetimeFigureOut">
               <a:rPr lang="en-US" smtClean="0"/>
-              <a:t>8/4/26</a:t>
+              <a:t>8/8/26</a:t>
             </a:fld>
             <a:endParaRPr lang="en-US"/>
           </a:p>
@@ -674,7 +674,7 @@
           <a:p>
             <a:fld id="{7855FD8B-6E15-6A40-8498-FD85B722A7EB}" type="datetimeFigureOut">
               <a:rPr lang="en-US" smtClean="0"/>
-              <a:t>8/4/26</a:t>
+              <a:t>8/8/26</a:t>
             </a:fld>
             <a:endParaRPr lang="en-US"/>
           </a:p>
@@ -874,7 +874,7 @@
           <a:p>
             <a:fld id="{7855FD8B-6E15-6A40-8498-FD85B722A7EB}" type="datetimeFigureOut">
               <a:rPr lang="en-US" smtClean="0"/>
-              <a:t>8/4/26</a:t>
+              <a:t>8/8/26</a:t>
             </a:fld>
             <a:endParaRPr lang="en-US"/>
           </a:p>
@@ -1150,7 +1150,7 @@
           <a:p>
             <a:fld id="{7855FD8B-6E15-6A40-8498-FD85B722A7EB}" type="datetimeFigureOut">
               <a:rPr lang="en-US" smtClean="0"/>
-              <a:t>8/4/26</a:t>
+              <a:t>8/8/26</a:t>
             </a:fld>
             <a:endParaRPr lang="en-US"/>
           </a:p>
@@ -1418,7 +1418,7 @@
           <a:p>
             <a:fld id="{7855FD8B-6E15-6A40-8498-FD85B722A7EB}" type="datetimeFigureOut">
               <a:rPr lang="en-US" smtClean="0"/>
-              <a:t>8/4/26</a:t>
+              <a:t>8/8/26</a:t>
             </a:fld>
             <a:endParaRPr lang="en-US"/>
           </a:p>
@@ -1833,7 +1833,7 @@
           <a:p>
             <a:fld id="{7855FD8B-6E15-6A40-8498-FD85B722A7EB}" type="datetimeFigureOut">
               <a:rPr lang="en-US" smtClean="0"/>
-              <a:t>8/4/26</a:t>
+              <a:t>8/8/26</a:t>
             </a:fld>
             <a:endParaRPr lang="en-US"/>
           </a:p>
@@ -1975,7 +1975,7 @@
           <a:p>
             <a:fld id="{7855FD8B-6E15-6A40-8498-FD85B722A7EB}" type="datetimeFigureOut">
               <a:rPr lang="en-US" smtClean="0"/>
-              <a:t>8/4/26</a:t>
+              <a:t>8/8/26</a:t>
             </a:fld>
             <a:endParaRPr lang="en-US"/>
           </a:p>
@@ -2088,7 +2088,7 @@
           <a:p>
             <a:fld id="{7855FD8B-6E15-6A40-8498-FD85B722A7EB}" type="datetimeFigureOut">
               <a:rPr lang="en-US" smtClean="0"/>
-              <a:t>8/4/26</a:t>
+              <a:t>8/8/26</a:t>
             </a:fld>
             <a:endParaRPr lang="en-US"/>
           </a:p>
@@ -2401,7 +2401,7 @@
           <a:p>
             <a:fld id="{7855FD8B-6E15-6A40-8498-FD85B722A7EB}" type="datetimeFigureOut">
               <a:rPr lang="en-US" smtClean="0"/>
-              <a:t>8/4/26</a:t>
+              <a:t>8/8/26</a:t>
             </a:fld>
             <a:endParaRPr lang="en-US"/>
           </a:p>
@@ -2690,7 +2690,7 @@
           <a:p>
             <a:fld id="{7855FD8B-6E15-6A40-8498-FD85B722A7EB}" type="datetimeFigureOut">
               <a:rPr lang="en-US" smtClean="0"/>
-              <a:t>8/4/26</a:t>
+              <a:t>8/8/26</a:t>
             </a:fld>
             <a:endParaRPr lang="en-US"/>
           </a:p>
@@ -2933,7 +2933,7 @@
           <a:p>
             <a:fld id="{7855FD8B-6E15-6A40-8498-FD85B722A7EB}" type="datetimeFigureOut">
               <a:rPr lang="en-US" smtClean="0"/>
-              <a:t>8/4/26</a:t>
+              <a:t>8/8/26</a:t>
             </a:fld>
             <a:endParaRPr lang="en-US"/>
           </a:p>
@@ -3670,7 +3670,9 @@
     <p:bg>
       <p:bgPr>
         <a:solidFill>
-          <a:schemeClr val="bg1"/>
+          <a:schemeClr val="bg1">
+            <a:lumMod val="95000"/>
+          </a:schemeClr>
         </a:solidFill>
         <a:effectLst/>
       </p:bgPr>
@@ -3758,13 +3760,8 @@
             </a:pPr>
             <a:r>
               <a:rPr lang="en-US" dirty="0"/>
-              <a:t>And now some more text which takes up rather more space than anything we’ve seen so far. Hopefully this will stress-test the rendering a </a:t>
-            </a:r>
-            <a:r>
-              <a:rPr lang="en-US"/>
-              <a:t>bit more.</a:t>
-            </a:r>
-            <a:endParaRPr lang="en-US" dirty="0"/>
+              <a:t>And now some more text which takes up rather more space than anything we’ve seen so far. Hopefully this will stress-test the rendering a bit more.</a:t>
+            </a:r>
           </a:p>
         </p:txBody>
       </p:sp>

</xml_diff>